<commit_message>
Re-render template_pitch_deck decks after excluding template_formal
The decks were re-rendered before the template_manifest/public_scope
cleanup that excluded template_formal (unrelated, unfinished concurrent
work). The committed artifacts baked in a stale '20 public exemplars'
count. Re-rendered with the corrected 19-exemplar live token so the
shipped decks match the actual public roster in this commit.

110/110 tests passing, 98.41% coverage. Diligence audit clean.
</commit_message>
<xml_diff>
--- a/projects/templates/template_pitch_deck/output/pptx/template_template_pitch_long.pptx
+++ b/projects/templates/template_pitch_deck/output/pptx/template_template_pitch_long.pptx
@@ -7233,7 +7233,7 @@
               </a:defRPr>
             </a:pPr>
             <a:r>
-              <a:t>•  projects/templates/ holds all 20 public exemplars: template_active_inference, template_autopoiesis, template_autoresearch_project, template_autoscientists, template_code_project, template_eda_notebook, template_formal, template_gold_refinement, template_literature_meta_analysis, template_madlib, template_methods_paper, template_newspaper, template_pitch_deck, template_pools_rules_tools, template_prose_project, template_search_project, template_sia, template_storybook, template_template, template_textbook.</a:t>
+              <a:t>•  projects/templates/ holds all 19 public exemplars: template_active_inference, template_autopoiesis, template_autoresearch_project, template_autoscientists, template_code_project, template_eda_notebook, template_gold_refinement, template_literature_meta_analysis, template_madlib, template_methods_paper, template_newspaper, template_pitch_deck, template_pools_rules_tools, template_prose_project, template_search_project, template_sia, template_storybook, template_template, template_textbook.</a:t>
             </a:r>
           </a:p>
           <a:p>
@@ -7263,7 +7263,7 @@
               </a:defRPr>
             </a:pPr>
             <a:r>
-              <a:t>•  Neither exemplar's coverage gate or drift check required any special-casing to add — the contract is uniform across all 20 projects, and the folder itself is the evidence, not a claim about it.</a:t>
+              <a:t>•  Neither exemplar's coverage gate or drift check required any special-casing to add — the contract is uniform across all 19 projects, and the folder itself is the evidence, not a claim about it.</a:t>
             </a:r>
           </a:p>
         </p:txBody>
@@ -10118,7 +10118,7 @@
               </a:defRPr>
             </a:pPr>
             <a:r>
-              <a:t>•  Every one of 20 public exemplars is measured independently, not summarized into one repo-wide percentage.</a:t>
+              <a:t>•  Every one of 19 public exemplars is measured independently, not summarized into one repo-wide percentage.</a:t>
             </a:r>
           </a:p>
           <a:p>
@@ -14746,7 +14746,7 @@
               </a:defRPr>
             </a:pPr>
             <a:r>
-              <a:t>•  One of 20 public exemplar templates in the same monorepo, each independently tested and coverage-gated.</a:t>
+              <a:t>•  One of 19 public exemplar templates in the same monorepo, each independently tested and coverage-gated.</a:t>
             </a:r>
           </a:p>
         </p:txBody>

</xml_diff>

<commit_message>
Complete accessibility, provenance, and exemplar release hardening
</commit_message>
<xml_diff>
--- a/projects/templates/template_pitch_deck/output/pptx/template_template_pitch_long.pptx
+++ b/projects/templates/template_pitch_deck/output/pptx/template_template_pitch_long.pptx
@@ -3936,7 +3936,7 @@
         <p:spPr>
           <a:xfrm>
             <a:off x="502920" y="1097280"/>
-            <a:ext cx="8138160" cy="3771900"/>
+            <a:ext cx="8138160" cy="2368296"/>
           </a:xfrm>
           <a:prstGeom prst="rect">
             <a:avLst/>
@@ -4144,7 +4144,7 @@
         <p:spPr>
           <a:xfrm>
             <a:off x="502920" y="1097280"/>
-            <a:ext cx="8138160" cy="3771900"/>
+            <a:ext cx="8138160" cy="2112264"/>
           </a:xfrm>
           <a:prstGeom prst="rect">
             <a:avLst/>
@@ -4352,7 +4352,7 @@
         <p:spPr>
           <a:xfrm>
             <a:off x="502920" y="1097280"/>
-            <a:ext cx="8138160" cy="3771900"/>
+            <a:ext cx="8138160" cy="2112264"/>
           </a:xfrm>
           <a:prstGeom prst="rect">
             <a:avLst/>
@@ -4560,7 +4560,7 @@
         <p:spPr>
           <a:xfrm>
             <a:off x="502920" y="1097280"/>
-            <a:ext cx="8138160" cy="3771900"/>
+            <a:ext cx="8138160" cy="2368296"/>
           </a:xfrm>
           <a:prstGeom prst="rect">
             <a:avLst/>
@@ -5329,7 +5329,7 @@
         <p:spPr>
           <a:xfrm>
             <a:off x="502920" y="1097280"/>
-            <a:ext cx="8138160" cy="3771900"/>
+            <a:ext cx="8138160" cy="1856232"/>
           </a:xfrm>
           <a:prstGeom prst="rect">
             <a:avLst/>
@@ -5537,7 +5537,7 @@
         <p:spPr>
           <a:xfrm>
             <a:off x="502920" y="1097280"/>
-            <a:ext cx="8138160" cy="3771900"/>
+            <a:ext cx="8138160" cy="2368296"/>
           </a:xfrm>
           <a:prstGeom prst="rect">
             <a:avLst/>
@@ -5779,7 +5779,7 @@
         <p:spPr>
           <a:xfrm>
             <a:off x="502920" y="1097280"/>
-            <a:ext cx="8138160" cy="3771900"/>
+            <a:ext cx="8138160" cy="2112264"/>
           </a:xfrm>
           <a:prstGeom prst="rect">
             <a:avLst/>
@@ -5987,7 +5987,7 @@
         <p:spPr>
           <a:xfrm>
             <a:off x="502920" y="1097280"/>
-            <a:ext cx="8138160" cy="3771900"/>
+            <a:ext cx="8138160" cy="2112264"/>
           </a:xfrm>
           <a:prstGeom prst="rect">
             <a:avLst/>
@@ -6360,7 +6360,7 @@
                   <a:srgbClr val="B3131A"/>
                 </a:solidFill>
               </a:rPr>
-              <a:t>130 tests</a:t>
+              <a:t>147 tests</a:t>
             </a:r>
           </a:p>
         </p:txBody>
@@ -6393,7 +6393,7 @@
                   <a:srgbClr val="0A0A0A"/>
                 </a:solidFill>
               </a:rPr>
-              <a:t>99.37% coverage on template_template's own source — the same gate every exemplar in the repo must pass. No partial-credit reporting path exists.</a:t>
+              <a:t>97.66% coverage on template_template's own source — the same gate every exemplar in the repo must pass. No partial-credit reporting path exists.</a:t>
             </a:r>
           </a:p>
         </p:txBody>
@@ -6802,7 +6802,7 @@
         <p:spPr>
           <a:xfrm>
             <a:off x="502920" y="1097280"/>
-            <a:ext cx="8138160" cy="3771900"/>
+            <a:ext cx="8138160" cy="2112264"/>
           </a:xfrm>
           <a:prstGeom prst="rect">
             <a:avLst/>
@@ -7209,7 +7209,7 @@
         <p:spPr>
           <a:xfrm>
             <a:off x="502920" y="1097280"/>
-            <a:ext cx="8138160" cy="3771900"/>
+            <a:ext cx="8138160" cy="2560320"/>
           </a:xfrm>
           <a:prstGeom prst="rect">
             <a:avLst/>
@@ -7233,7 +7233,7 @@
               </a:defRPr>
             </a:pPr>
             <a:r>
-              <a:t>•  projects/templates/ holds all 23 public exemplars: template_active_inference, template_autopoiesis, template_autoresearch_project, template_autoscientists, template_code_project, template_data_descriptor, template_eda_notebook, template_formal, template_gold_refinement, template_literature_meta_analysis, template_madlib, template_methods_paper, template_newspaper, template_pitch_deck, template_pools_rules_tools, template_prose_project, template_redacted_report, template_registered_report, template_search_project, template_sia, template_storybook, template_template, template_textbook.</a:t>
+              <a:t>•  projects/templates/ holds all 24 public exemplars: template_active_inference, template_advanced_literature_review, template_autopoiesis, template_autoresearch_project, template_autoscientists, template_code_project, template_data_descriptor, template_eda_notebook, template_formal, template_gold_refinement, template_literature_meta_analysis, template_madlib, template_methods_paper, template_newspaper, template_pitch_deck, template_pools_rules_tools, template_prose_project, template_redacted_report, template_registered_report, template_search_project, template_sia, template_storybook, template_template, template_textbook.</a:t>
             </a:r>
           </a:p>
           <a:p>
@@ -7263,7 +7263,7 @@
               </a:defRPr>
             </a:pPr>
             <a:r>
-              <a:t>•  Neither exemplar's coverage gate or drift check required any special-casing to add — the contract is uniform across all 23 projects, and the folder itself is the evidence, not a claim about it.</a:t>
+              <a:t>•  Neither exemplar's coverage gate or drift check required any special-casing to add — the contract is uniform across all 24 projects, and the folder itself is the evidence, not a claim about it.</a:t>
             </a:r>
           </a:p>
         </p:txBody>
@@ -7451,7 +7451,7 @@
         <p:spPr>
           <a:xfrm>
             <a:off x="502920" y="1097280"/>
-            <a:ext cx="8138160" cy="3771900"/>
+            <a:ext cx="8138160" cy="1856232"/>
           </a:xfrm>
           <a:prstGeom prst="rect">
             <a:avLst/>
@@ -7824,7 +7824,7 @@
         <p:spPr>
           <a:xfrm>
             <a:off x="502920" y="1097280"/>
-            <a:ext cx="8138160" cy="3771900"/>
+            <a:ext cx="8138160" cy="2368296"/>
           </a:xfrm>
           <a:prstGeom prst="rect">
             <a:avLst/>
@@ -8032,7 +8032,7 @@
         <p:spPr>
           <a:xfrm>
             <a:off x="502920" y="1097280"/>
-            <a:ext cx="8138160" cy="3771900"/>
+            <a:ext cx="8138160" cy="2368296"/>
           </a:xfrm>
           <a:prstGeom prst="rect">
             <a:avLst/>
@@ -8240,7 +8240,7 @@
         <p:spPr>
           <a:xfrm>
             <a:off x="502920" y="1097280"/>
-            <a:ext cx="8138160" cy="3771900"/>
+            <a:ext cx="8138160" cy="2112264"/>
           </a:xfrm>
           <a:prstGeom prst="rect">
             <a:avLst/>
@@ -8613,7 +8613,7 @@
         <p:spPr>
           <a:xfrm>
             <a:off x="502920" y="1097280"/>
-            <a:ext cx="8138160" cy="3771900"/>
+            <a:ext cx="8138160" cy="2112264"/>
           </a:xfrm>
           <a:prstGeom prst="rect">
             <a:avLst/>
@@ -8821,7 +8821,7 @@
         <p:spPr>
           <a:xfrm>
             <a:off x="502920" y="1097280"/>
-            <a:ext cx="8138160" cy="3771900"/>
+            <a:ext cx="8138160" cy="2112264"/>
           </a:xfrm>
           <a:prstGeom prst="rect">
             <a:avLst/>
@@ -9194,7 +9194,7 @@
         <p:spPr>
           <a:xfrm>
             <a:off x="502920" y="1097280"/>
-            <a:ext cx="8138160" cy="3771900"/>
+            <a:ext cx="8138160" cy="2560320"/>
           </a:xfrm>
           <a:prstGeom prst="rect">
             <a:avLst/>
@@ -9634,7 +9634,7 @@
         <p:spPr>
           <a:xfrm>
             <a:off x="502920" y="1097280"/>
-            <a:ext cx="8138160" cy="3771900"/>
+            <a:ext cx="8138160" cy="2560320"/>
           </a:xfrm>
           <a:prstGeom prst="rect">
             <a:avLst/>
@@ -9876,7 +9876,7 @@
         <p:spPr>
           <a:xfrm>
             <a:off x="502920" y="1097280"/>
-            <a:ext cx="8138160" cy="3771900"/>
+            <a:ext cx="8138160" cy="2368296"/>
           </a:xfrm>
           <a:prstGeom prst="rect">
             <a:avLst/>
@@ -10118,7 +10118,7 @@
         <p:spPr>
           <a:xfrm>
             <a:off x="502920" y="1097280"/>
-            <a:ext cx="8138160" cy="3771900"/>
+            <a:ext cx="8138160" cy="1600200"/>
           </a:xfrm>
           <a:prstGeom prst="rect">
             <a:avLst/>
@@ -10142,7 +10142,7 @@
               </a:defRPr>
             </a:pPr>
             <a:r>
-              <a:t>•  Every one of 23 public exemplars is measured independently, not summarized into one repo-wide percentage.</a:t>
+              <a:t>•  Every one of 24 public exemplars is measured independently, not summarized into one repo-wide percentage.</a:t>
             </a:r>
           </a:p>
           <a:p>
@@ -10157,7 +10157,7 @@
               </a:defRPr>
             </a:pPr>
             <a:r>
-              <a:t>•  The chart on the next slide is generated from the same docs/_generated/COUNTS.md factsheet this deck's own 99.37% figure comes from — one source of truth, two presentations.</a:t>
+              <a:t>•  The chart on the next slide is generated from the same docs/_generated/COUNTS.md factsheet this deck's own 97.66% figure comes from — one source of truth, two presentations.</a:t>
             </a:r>
           </a:p>
         </p:txBody>
@@ -10353,7 +10353,7 @@
         <p:spPr>
           <a:xfrm>
             <a:off x="914400" y="914400"/>
-            <a:ext cx="7315200" cy="4894534"/>
+            <a:ext cx="7315200" cy="5107340"/>
           </a:xfrm>
           <a:prstGeom prst="rect">
             <a:avLst/>
@@ -10906,7 +10906,7 @@
         <p:spPr>
           <a:xfrm>
             <a:off x="502920" y="1097280"/>
-            <a:ext cx="8138160" cy="3771900"/>
+            <a:ext cx="8138160" cy="2560320"/>
           </a:xfrm>
           <a:prstGeom prst="rect">
             <a:avLst/>
@@ -11148,7 +11148,7 @@
         <p:spPr>
           <a:xfrm>
             <a:off x="502920" y="1097280"/>
-            <a:ext cx="8138160" cy="3771900"/>
+            <a:ext cx="8138160" cy="2560320"/>
           </a:xfrm>
           <a:prstGeom prst="rect">
             <a:avLst/>
@@ -11390,7 +11390,7 @@
         <p:spPr>
           <a:xfrm>
             <a:off x="502920" y="1097280"/>
-            <a:ext cx="8138160" cy="3771900"/>
+            <a:ext cx="8138160" cy="2560320"/>
           </a:xfrm>
           <a:prstGeom prst="rect">
             <a:avLst/>
@@ -11812,7 +11812,7 @@
         <p:spPr>
           <a:xfrm>
             <a:off x="502920" y="1097280"/>
-            <a:ext cx="8138160" cy="3771900"/>
+            <a:ext cx="8138160" cy="2560320"/>
           </a:xfrm>
           <a:prstGeom prst="rect">
             <a:avLst/>
@@ -11836,7 +11836,7 @@
               </a:defRPr>
             </a:pPr>
             <a:r>
-              <a:t>•  25 importable subpackages, 673 tracked Python files total under infrastructure/ — a real inventory anyone can `git ls-files` themselves, not a claimed abstraction.</a:t>
+              <a:t>•  25 importable subpackages, 744 tracked Python files total under infrastructure/ — a real inventory anyone can `git ls-files` themselves, not a claimed abstraction.</a:t>
             </a:r>
           </a:p>
           <a:p>
@@ -11851,7 +11851,7 @@
               </a:defRPr>
             </a:pPr>
             <a:r>
-              <a:t>•  The largest single subpackage, core, holds 112 files — still a minority of the whole, not a monolith wearing a modular label.</a:t>
+              <a:t>•  The largest single subpackage, core, holds 128 files — still a minority of the whole, not a monolith wearing a modular label.</a:t>
             </a:r>
           </a:p>
           <a:p>
@@ -12267,7 +12267,7 @@
         <p:spPr>
           <a:xfrm>
             <a:off x="502920" y="1097280"/>
-            <a:ext cx="8138160" cy="3771900"/>
+            <a:ext cx="8138160" cy="2560320"/>
           </a:xfrm>
           <a:prstGeom prst="rect">
             <a:avLst/>
@@ -12640,7 +12640,7 @@
         <p:spPr>
           <a:xfrm>
             <a:off x="502920" y="1097280"/>
-            <a:ext cx="8138160" cy="3771900"/>
+            <a:ext cx="8138160" cy="2112264"/>
           </a:xfrm>
           <a:prstGeom prst="rect">
             <a:avLst/>
@@ -12848,7 +12848,7 @@
         <p:spPr>
           <a:xfrm>
             <a:off x="502920" y="1097280"/>
-            <a:ext cx="8138160" cy="3771900"/>
+            <a:ext cx="8138160" cy="2368296"/>
           </a:xfrm>
           <a:prstGeom prst="rect">
             <a:avLst/>
@@ -13056,7 +13056,7 @@
         <p:spPr>
           <a:xfrm>
             <a:off x="502920" y="1097280"/>
-            <a:ext cx="8138160" cy="3771900"/>
+            <a:ext cx="8138160" cy="1856232"/>
           </a:xfrm>
           <a:prstGeom prst="rect">
             <a:avLst/>
@@ -13264,7 +13264,7 @@
         <p:spPr>
           <a:xfrm>
             <a:off x="502920" y="1097280"/>
-            <a:ext cx="8138160" cy="3771900"/>
+            <a:ext cx="8138160" cy="2112264"/>
           </a:xfrm>
           <a:prstGeom prst="rect">
             <a:avLst/>
@@ -13472,7 +13472,7 @@
         <p:spPr>
           <a:xfrm>
             <a:off x="502920" y="1097280"/>
-            <a:ext cx="8138160" cy="3771900"/>
+            <a:ext cx="8138160" cy="2560320"/>
           </a:xfrm>
           <a:prstGeom prst="rect">
             <a:avLst/>
@@ -13845,7 +13845,7 @@
         <p:spPr>
           <a:xfrm>
             <a:off x="502920" y="1097280"/>
-            <a:ext cx="8138160" cy="3771900"/>
+            <a:ext cx="8138160" cy="2368296"/>
           </a:xfrm>
           <a:prstGeom prst="rect">
             <a:avLst/>
@@ -14068,7 +14068,7 @@
         <p:spPr>
           <a:xfrm>
             <a:off x="502920" y="1097280"/>
-            <a:ext cx="8138160" cy="3771900"/>
+            <a:ext cx="8138160" cy="1344168"/>
           </a:xfrm>
           <a:prstGeom prst="rect">
             <a:avLst/>
@@ -14508,7 +14508,7 @@
         <p:spPr>
           <a:xfrm>
             <a:off x="502920" y="1097280"/>
-            <a:ext cx="8138160" cy="3771900"/>
+            <a:ext cx="8138160" cy="2560320"/>
           </a:xfrm>
           <a:prstGeom prst="rect">
             <a:avLst/>
@@ -14716,7 +14716,7 @@
         <p:spPr>
           <a:xfrm>
             <a:off x="502920" y="1097280"/>
-            <a:ext cx="8138160" cy="3771900"/>
+            <a:ext cx="8138160" cy="2112264"/>
           </a:xfrm>
           <a:prstGeom prst="rect">
             <a:avLst/>
@@ -14770,7 +14770,7 @@
               </a:defRPr>
             </a:pPr>
             <a:r>
-              <a:t>•  One of 23 public exemplar templates in the same monorepo, each independently tested and coverage-gated.</a:t>
+              <a:t>•  One of 24 public exemplar templates in the same monorepo, each independently tested and coverage-gated.</a:t>
             </a:r>
           </a:p>
         </p:txBody>

</xml_diff>